<commit_message>
Cascade: kept bar + drop box must exactly equal the previous column
Fixes a correctness bug the owner spotted: a stage's bar plus its remainder
box represent precisely the previous column's total, yet the 2pt gap added
height and small remainders were inflated to a minimum label height —
making column N visibly longer than column N-1.

Drop boxes are now bottom-anchored at the previous bar's exact bottom edge:
the gap is carved out of the box, and when the label needs more height than
the remainder's true share, the box grows upward over the bar instead of
downward past the total. Locked in by an invariant test across every split
plus a tiny-remainder case; showcase and snapshot regenerated. 428 tests.

Co-Authored-By: Claude Fable 5 <noreply@anthropic.com>
Claude-Session: https://claude.ai/code/session_01P4gY353FNLRGX4VFnfJjiF
</commit_message>
<xml_diff>
--- a/examples/showcase.pptx
+++ b/examples/showcase.pptx
@@ -19002,7 +19002,7 @@
         </p:nvSpPr>
         <p:spPr>
           <a:xfrm>
-            <a:off x="4720565" y="4917315"/>
+            <a:off x="4720565" y="4749800"/>
             <a:ext cx="1239266" cy="368300"/>
           </a:xfrm>
           <a:prstGeom prst="rect">
@@ -19022,7 +19022,7 @@
         </p:nvSpPr>
         <p:spPr>
           <a:xfrm>
-            <a:off x="4745965" y="4930015"/>
+            <a:off x="4745965" y="4762500"/>
             <a:ext cx="1188466" cy="177800"/>
           </a:xfrm>
           <a:prstGeom prst="rect">
@@ -19061,7 +19061,7 @@
         </p:nvSpPr>
         <p:spPr>
           <a:xfrm>
-            <a:off x="4745965" y="5101465"/>
+            <a:off x="4745965" y="4933950"/>
             <a:ext cx="1188466" cy="177800"/>
           </a:xfrm>
           <a:prstGeom prst="rect">
@@ -19238,7 +19238,7 @@
         <p:spPr>
           <a:xfrm>
             <a:off x="6231865" y="4177016"/>
-            <a:ext cx="1239266" cy="740298"/>
+            <a:ext cx="1239266" cy="714898"/>
           </a:xfrm>
           <a:prstGeom prst="rect">
             <a:avLst/>
@@ -19257,7 +19257,7 @@
         </p:nvSpPr>
         <p:spPr>
           <a:xfrm>
-            <a:off x="6257265" y="4375715"/>
+            <a:off x="6257265" y="4363015"/>
             <a:ext cx="1188466" cy="177800"/>
           </a:xfrm>
           <a:prstGeom prst="rect">
@@ -19296,7 +19296,7 @@
         </p:nvSpPr>
         <p:spPr>
           <a:xfrm>
-            <a:off x="6257265" y="4547165"/>
+            <a:off x="6257265" y="4534465"/>
             <a:ext cx="1188466" cy="177800"/>
           </a:xfrm>
           <a:prstGeom prst="rect">
@@ -19473,7 +19473,7 @@
         <p:spPr>
           <a:xfrm>
             <a:off x="7743165" y="3736872"/>
-            <a:ext cx="1239266" cy="440144"/>
+            <a:ext cx="1239266" cy="414744"/>
           </a:xfrm>
           <a:prstGeom prst="rect">
             <a:avLst/>
@@ -19492,7 +19492,7 @@
         </p:nvSpPr>
         <p:spPr>
           <a:xfrm>
-            <a:off x="7768565" y="3785494"/>
+            <a:off x="7768565" y="3772794"/>
             <a:ext cx="1188466" cy="177800"/>
           </a:xfrm>
           <a:prstGeom prst="rect">
@@ -19531,7 +19531,7 @@
         </p:nvSpPr>
         <p:spPr>
           <a:xfrm>
-            <a:off x="7768565" y="3956944"/>
+            <a:off x="7768565" y="3944244"/>
             <a:ext cx="1188466" cy="177800"/>
           </a:xfrm>
           <a:prstGeom prst="rect">

</xml_diff>

<commit_message>
Cascade: halve the spacing between columns
Bars widen from 82% to 91% of the slot, halving the inter-column gap
(the owner's tuning after seeing the render). Group header bands and
outside labels track the new edges automatically. Snapshot + showcase
regenerated.

Co-Authored-By: Claude Fable 5 <noreply@anthropic.com>
Claude-Session: https://claude.ai/code/session_01P4gY353FNLRGX4VFnfJjiF
</commit_message>
<xml_diff>
--- a/examples/showcase.pptx
+++ b/examples/showcase.pptx
@@ -18649,8 +18649,8 @@
         </p:nvSpPr>
         <p:spPr>
           <a:xfrm>
-            <a:off x="3209265" y="1803400"/>
-            <a:ext cx="2750566" cy="190500"/>
+            <a:off x="3141256" y="1803400"/>
+            <a:ext cx="2886583" cy="190500"/>
           </a:xfrm>
           <a:prstGeom prst="rect">
             <a:avLst/>
@@ -18669,8 +18669,8 @@
         </p:nvSpPr>
         <p:spPr>
           <a:xfrm>
-            <a:off x="3209265" y="1803400"/>
-            <a:ext cx="2750566" cy="190500"/>
+            <a:off x="3141256" y="1803400"/>
+            <a:ext cx="2886583" cy="190500"/>
           </a:xfrm>
           <a:prstGeom prst="rect">
             <a:avLst/>
@@ -18708,8 +18708,8 @@
         </p:nvSpPr>
         <p:spPr>
           <a:xfrm>
-            <a:off x="6231865" y="1803400"/>
-            <a:ext cx="2750566" cy="190500"/>
+            <a:off x="6163856" y="1803400"/>
+            <a:ext cx="2886583" cy="190500"/>
           </a:xfrm>
           <a:prstGeom prst="rect">
             <a:avLst/>
@@ -18728,8 +18728,8 @@
         </p:nvSpPr>
         <p:spPr>
           <a:xfrm>
-            <a:off x="6231865" y="1803400"/>
-            <a:ext cx="2750566" cy="190500"/>
+            <a:off x="6163856" y="1803400"/>
+            <a:ext cx="2886583" cy="190500"/>
           </a:xfrm>
           <a:prstGeom prst="rect">
             <a:avLst/>
@@ -18767,8 +18767,8 @@
         </p:nvSpPr>
         <p:spPr>
           <a:xfrm>
-            <a:off x="3209265" y="2070100"/>
-            <a:ext cx="1239266" cy="3048000"/>
+            <a:off x="3141256" y="2070100"/>
+            <a:ext cx="1375283" cy="3048000"/>
           </a:xfrm>
           <a:prstGeom prst="rect">
             <a:avLst/>
@@ -18787,8 +18787,8 @@
         </p:nvSpPr>
         <p:spPr>
           <a:xfrm>
-            <a:off x="3234665" y="2618740"/>
-            <a:ext cx="1188466" cy="177800"/>
+            <a:off x="3166656" y="2618740"/>
+            <a:ext cx="1324483" cy="177800"/>
           </a:xfrm>
           <a:prstGeom prst="rect">
             <a:avLst/>
@@ -18826,8 +18826,8 @@
         </p:nvSpPr>
         <p:spPr>
           <a:xfrm>
-            <a:off x="3234665" y="3498850"/>
-            <a:ext cx="1188466" cy="177800"/>
+            <a:off x="3166656" y="3498850"/>
+            <a:ext cx="1324483" cy="177800"/>
           </a:xfrm>
           <a:prstGeom prst="rect">
             <a:avLst/>
@@ -18865,8 +18865,8 @@
         </p:nvSpPr>
         <p:spPr>
           <a:xfrm>
-            <a:off x="4720565" y="2070100"/>
-            <a:ext cx="1239266" cy="2821815"/>
+            <a:off x="4652556" y="2070100"/>
+            <a:ext cx="1375283" cy="2821815"/>
           </a:xfrm>
           <a:prstGeom prst="rect">
             <a:avLst/>
@@ -18885,8 +18885,8 @@
         </p:nvSpPr>
         <p:spPr>
           <a:xfrm>
-            <a:off x="4745965" y="2578027"/>
-            <a:ext cx="1188466" cy="177800"/>
+            <a:off x="4677956" y="2578027"/>
+            <a:ext cx="1324483" cy="177800"/>
           </a:xfrm>
           <a:prstGeom prst="rect">
             <a:avLst/>
@@ -18924,8 +18924,8 @@
         </p:nvSpPr>
         <p:spPr>
           <a:xfrm>
-            <a:off x="4745965" y="3385757"/>
-            <a:ext cx="1188466" cy="177800"/>
+            <a:off x="4677956" y="3385757"/>
+            <a:ext cx="1324483" cy="177800"/>
           </a:xfrm>
           <a:prstGeom prst="rect">
             <a:avLst/>
@@ -18963,8 +18963,8 @@
         </p:nvSpPr>
         <p:spPr>
           <a:xfrm>
-            <a:off x="4745965" y="3569907"/>
-            <a:ext cx="1188466" cy="177800"/>
+            <a:off x="4677956" y="3569907"/>
+            <a:ext cx="1324483" cy="177800"/>
           </a:xfrm>
           <a:prstGeom prst="rect">
             <a:avLst/>
@@ -19002,8 +19002,8 @@
         </p:nvSpPr>
         <p:spPr>
           <a:xfrm>
-            <a:off x="4720565" y="4891915"/>
-            <a:ext cx="1239266" cy="226185"/>
+            <a:off x="4652556" y="4891915"/>
+            <a:ext cx="1375283" cy="226185"/>
           </a:xfrm>
           <a:prstGeom prst="rect">
             <a:avLst/>
@@ -19027,8 +19027,8 @@
         </p:nvSpPr>
         <p:spPr>
           <a:xfrm>
-            <a:off x="4745965" y="4891915"/>
-            <a:ext cx="1188466" cy="226185"/>
+            <a:off x="4677956" y="4891915"/>
+            <a:ext cx="1324483" cy="226185"/>
           </a:xfrm>
           <a:prstGeom prst="rect">
             <a:avLst/>
@@ -19105,8 +19105,8 @@
         </p:nvSpPr>
         <p:spPr>
           <a:xfrm>
-            <a:off x="6231865" y="2070100"/>
-            <a:ext cx="1239266" cy="2081516"/>
+            <a:off x="6163856" y="2070100"/>
+            <a:ext cx="1375283" cy="2081516"/>
           </a:xfrm>
           <a:prstGeom prst="rect">
             <a:avLst/>
@@ -19125,8 +19125,8 @@
         </p:nvSpPr>
         <p:spPr>
           <a:xfrm>
-            <a:off x="6257265" y="2444773"/>
-            <a:ext cx="1188466" cy="177800"/>
+            <a:off x="6189256" y="2444773"/>
+            <a:ext cx="1324483" cy="177800"/>
           </a:xfrm>
           <a:prstGeom prst="rect">
             <a:avLst/>
@@ -19164,8 +19164,8 @@
         </p:nvSpPr>
         <p:spPr>
           <a:xfrm>
-            <a:off x="6257265" y="3015608"/>
-            <a:ext cx="1188466" cy="177800"/>
+            <a:off x="6189256" y="3015608"/>
+            <a:ext cx="1324483" cy="177800"/>
           </a:xfrm>
           <a:prstGeom prst="rect">
             <a:avLst/>
@@ -19203,8 +19203,8 @@
         </p:nvSpPr>
         <p:spPr>
           <a:xfrm>
-            <a:off x="6257265" y="3199758"/>
-            <a:ext cx="1188466" cy="177800"/>
+            <a:off x="6189256" y="3199758"/>
+            <a:ext cx="1324483" cy="177800"/>
           </a:xfrm>
           <a:prstGeom prst="rect">
             <a:avLst/>
@@ -19242,8 +19242,8 @@
         </p:nvSpPr>
         <p:spPr>
           <a:xfrm>
-            <a:off x="6231865" y="4151616"/>
-            <a:ext cx="1239266" cy="740298"/>
+            <a:off x="6163856" y="4151616"/>
+            <a:ext cx="1375283" cy="740298"/>
           </a:xfrm>
           <a:prstGeom prst="rect">
             <a:avLst/>
@@ -19267,8 +19267,8 @@
         </p:nvSpPr>
         <p:spPr>
           <a:xfrm>
-            <a:off x="6257265" y="4350315"/>
-            <a:ext cx="1188466" cy="177800"/>
+            <a:off x="6189256" y="4350315"/>
+            <a:ext cx="1324483" cy="177800"/>
           </a:xfrm>
           <a:prstGeom prst="rect">
             <a:avLst/>
@@ -19306,8 +19306,8 @@
         </p:nvSpPr>
         <p:spPr>
           <a:xfrm>
-            <a:off x="6257265" y="4521765"/>
-            <a:ext cx="1188466" cy="177800"/>
+            <a:off x="6189256" y="4521765"/>
+            <a:ext cx="1324483" cy="177800"/>
           </a:xfrm>
           <a:prstGeom prst="rect">
             <a:avLst/>
@@ -19345,8 +19345,8 @@
         </p:nvSpPr>
         <p:spPr>
           <a:xfrm>
-            <a:off x="7743165" y="2070100"/>
-            <a:ext cx="1239266" cy="1641372"/>
+            <a:off x="7675156" y="2070100"/>
+            <a:ext cx="1375283" cy="1641372"/>
           </a:xfrm>
           <a:prstGeom prst="rect">
             <a:avLst/>
@@ -19365,8 +19365,8 @@
         </p:nvSpPr>
         <p:spPr>
           <a:xfrm>
-            <a:off x="7768565" y="2365547"/>
-            <a:ext cx="1188466" cy="177800"/>
+            <a:off x="7700556" y="2365547"/>
+            <a:ext cx="1324483" cy="177800"/>
           </a:xfrm>
           <a:prstGeom prst="rect">
             <a:avLst/>
@@ -19404,8 +19404,8 @@
         </p:nvSpPr>
         <p:spPr>
           <a:xfrm>
-            <a:off x="7768565" y="2795536"/>
-            <a:ext cx="1188466" cy="177800"/>
+            <a:off x="7700556" y="2795536"/>
+            <a:ext cx="1324483" cy="177800"/>
           </a:xfrm>
           <a:prstGeom prst="rect">
             <a:avLst/>
@@ -19443,8 +19443,8 @@
         </p:nvSpPr>
         <p:spPr>
           <a:xfrm>
-            <a:off x="7768565" y="2979686"/>
-            <a:ext cx="1188466" cy="177800"/>
+            <a:off x="7700556" y="2979686"/>
+            <a:ext cx="1324483" cy="177800"/>
           </a:xfrm>
           <a:prstGeom prst="rect">
             <a:avLst/>
@@ -19482,8 +19482,8 @@
         </p:nvSpPr>
         <p:spPr>
           <a:xfrm>
-            <a:off x="7743165" y="3711472"/>
-            <a:ext cx="1239266" cy="440144"/>
+            <a:off x="7675156" y="3711472"/>
+            <a:ext cx="1375283" cy="440144"/>
           </a:xfrm>
           <a:prstGeom prst="rect">
             <a:avLst/>
@@ -19507,8 +19507,8 @@
         </p:nvSpPr>
         <p:spPr>
           <a:xfrm>
-            <a:off x="7768565" y="3760094"/>
-            <a:ext cx="1188466" cy="177800"/>
+            <a:off x="7700556" y="3760094"/>
+            <a:ext cx="1324483" cy="177800"/>
           </a:xfrm>
           <a:prstGeom prst="rect">
             <a:avLst/>
@@ -19546,8 +19546,8 @@
         </p:nvSpPr>
         <p:spPr>
           <a:xfrm>
-            <a:off x="7768565" y="3931544"/>
-            <a:ext cx="1188466" cy="177800"/>
+            <a:off x="7700556" y="3931544"/>
+            <a:ext cx="1324483" cy="177800"/>
           </a:xfrm>
           <a:prstGeom prst="rect">
             <a:avLst/>

</xml_diff>